<commit_message>
feat: add first-class tables and text runs
</commit_message>
<xml_diff>
--- a/testdata/pptx/styled-text.pptx
+++ b/testdata/pptx/styled-text.pptx
@@ -151,16 +151,18 @@
                   </a:schemeClr>
                 </a:solidFill>
               </a:rPr>
-              <a:t>Hello </a:t>
+              <a:t>Hello</a:t>
             </a:r>
             <a:r>
               <a:rPr sz="1800"/>
-              <a:t>theme</a:t>
+              <a:t> theme</a:t>
             </a:r>
           </a:p>
           <a:p>
             <a:r>
-              <a:rPr sz="1800" i="1"/>
+              <a:rPr sz="1800" i="1">
+                <a:hlinkClick r:id="rIdStyledHyper"/>
+              </a:rPr>
               <a:t>Second paragraph</a:t>
             </a:r>
           </a:p>

</xml_diff>

<commit_message>
First-class tables and per-run text styles (schema 1.4) (#14)
* feat: add first-class tables and text runs

* fix: complete and reconcile tables/runs lean+compact output

* docs: reconcile tables and runs output contracts
</commit_message>
<xml_diff>
--- a/testdata/pptx/styled-text.pptx
+++ b/testdata/pptx/styled-text.pptx
@@ -151,16 +151,18 @@
                   </a:schemeClr>
                 </a:solidFill>
               </a:rPr>
-              <a:t>Hello </a:t>
+              <a:t>Hello</a:t>
             </a:r>
             <a:r>
               <a:rPr sz="1800"/>
-              <a:t>theme</a:t>
+              <a:t> theme</a:t>
             </a:r>
           </a:p>
           <a:p>
             <a:r>
-              <a:rPr sz="1800" i="1"/>
+              <a:rPr sz="1800" i="1">
+                <a:hlinkClick r:id="rIdStyledHyper"/>
+              </a:rPr>
               <a:t>Second paragraph</a:t>
             </a:r>
           </a:p>

</xml_diff>